<commit_message>
changed results graph to use recall
</commit_message>
<xml_diff>
--- a/draft_poster.pptx
+++ b/draft_poster.pptx
@@ -4933,7 +4933,7 @@
           <p:nvPr>
             <p:extLst>
               <p:ext uri="{D42A27DB-BD31-4B8C-83A1-F6EECF244321}">
-                <p14:modId xmlns:p14="http://schemas.microsoft.com/office/powerpoint/2010/main" val="2732456321"/>
+                <p14:modId xmlns:p14="http://schemas.microsoft.com/office/powerpoint/2010/main" val="343582800"/>
               </p:ext>
             </p:extLst>
           </p:nvPr>
@@ -7344,10 +7344,10 @@
       </p:graphicFrame>
       <p:pic>
         <p:nvPicPr>
-          <p:cNvPr id="5" name="Picture 4">
+          <p:cNvPr id="6" name="Picture 5" descr="A graph of a number of cases&#10;&#10;AI-generated content may be incorrect.">
             <a:extLst>
               <a:ext uri="{FF2B5EF4-FFF2-40B4-BE49-F238E27FC236}">
-                <a16:creationId xmlns:a16="http://schemas.microsoft.com/office/drawing/2014/main" id="{9601B7CB-6BF7-14CA-389E-B89EB8EACD1A}"/>
+                <a16:creationId xmlns:a16="http://schemas.microsoft.com/office/drawing/2014/main" id="{2C8C4FA9-43F5-AF9D-CFDC-FA2E1A58AB73}"/>
               </a:ext>
             </a:extLst>
           </p:cNvPr>
@@ -7357,15 +7357,21 @@
           <p:nvPr/>
         </p:nvPicPr>
         <p:blipFill>
-          <a:blip r:embed="rId3"/>
+          <a:blip r:embed="rId3">
+            <a:extLst>
+              <a:ext uri="{28A0092B-C50C-407E-A947-70E740481C1C}">
+                <a14:useLocalDpi xmlns:a14="http://schemas.microsoft.com/office/drawing/2010/main" val="0"/>
+              </a:ext>
+            </a:extLst>
+          </a:blip>
           <a:stretch>
             <a:fillRect/>
           </a:stretch>
         </p:blipFill>
         <p:spPr>
           <a:xfrm>
-            <a:off x="10966652" y="12023594"/>
-            <a:ext cx="8764280" cy="6713673"/>
+            <a:off x="10698161" y="11934995"/>
+            <a:ext cx="10143693" cy="7190381"/>
           </a:xfrm>
           <a:prstGeom prst="rect">
             <a:avLst/>

</xml_diff>

<commit_message>
citations and previous work
</commit_message>
<xml_diff>
--- a/draft_poster.pptx
+++ b/draft_poster.pptx
@@ -243,7 +243,7 @@
           <a:p>
             <a:fld id="{C9D56EB1-F2BE-4898-8B6B-5560BA3C98FF}" type="datetimeFigureOut">
               <a:rPr lang="en-US" smtClean="0"/>
-              <a:t>10/24/2025</a:t>
+              <a:t>10/27/2025</a:t>
             </a:fld>
             <a:endParaRPr lang="en-US"/>
           </a:p>
@@ -413,7 +413,7 @@
           <a:p>
             <a:fld id="{C9D56EB1-F2BE-4898-8B6B-5560BA3C98FF}" type="datetimeFigureOut">
               <a:rPr lang="en-US" smtClean="0"/>
-              <a:t>10/24/2025</a:t>
+              <a:t>10/27/2025</a:t>
             </a:fld>
             <a:endParaRPr lang="en-US"/>
           </a:p>
@@ -593,7 +593,7 @@
           <a:p>
             <a:fld id="{C9D56EB1-F2BE-4898-8B6B-5560BA3C98FF}" type="datetimeFigureOut">
               <a:rPr lang="en-US" smtClean="0"/>
-              <a:t>10/24/2025</a:t>
+              <a:t>10/27/2025</a:t>
             </a:fld>
             <a:endParaRPr lang="en-US"/>
           </a:p>
@@ -763,7 +763,7 @@
           <a:p>
             <a:fld id="{C9D56EB1-F2BE-4898-8B6B-5560BA3C98FF}" type="datetimeFigureOut">
               <a:rPr lang="en-US" smtClean="0"/>
-              <a:t>10/24/2025</a:t>
+              <a:t>10/27/2025</a:t>
             </a:fld>
             <a:endParaRPr lang="en-US"/>
           </a:p>
@@ -1007,7 +1007,7 @@
           <a:p>
             <a:fld id="{C9D56EB1-F2BE-4898-8B6B-5560BA3C98FF}" type="datetimeFigureOut">
               <a:rPr lang="en-US" smtClean="0"/>
-              <a:t>10/24/2025</a:t>
+              <a:t>10/27/2025</a:t>
             </a:fld>
             <a:endParaRPr lang="en-US"/>
           </a:p>
@@ -1239,7 +1239,7 @@
           <a:p>
             <a:fld id="{C9D56EB1-F2BE-4898-8B6B-5560BA3C98FF}" type="datetimeFigureOut">
               <a:rPr lang="en-US" smtClean="0"/>
-              <a:t>10/24/2025</a:t>
+              <a:t>10/27/2025</a:t>
             </a:fld>
             <a:endParaRPr lang="en-US"/>
           </a:p>
@@ -1606,7 +1606,7 @@
           <a:p>
             <a:fld id="{C9D56EB1-F2BE-4898-8B6B-5560BA3C98FF}" type="datetimeFigureOut">
               <a:rPr lang="en-US" smtClean="0"/>
-              <a:t>10/24/2025</a:t>
+              <a:t>10/27/2025</a:t>
             </a:fld>
             <a:endParaRPr lang="en-US"/>
           </a:p>
@@ -1724,7 +1724,7 @@
           <a:p>
             <a:fld id="{C9D56EB1-F2BE-4898-8B6B-5560BA3C98FF}" type="datetimeFigureOut">
               <a:rPr lang="en-US" smtClean="0"/>
-              <a:t>10/24/2025</a:t>
+              <a:t>10/27/2025</a:t>
             </a:fld>
             <a:endParaRPr lang="en-US"/>
           </a:p>
@@ -1819,7 +1819,7 @@
           <a:p>
             <a:fld id="{C9D56EB1-F2BE-4898-8B6B-5560BA3C98FF}" type="datetimeFigureOut">
               <a:rPr lang="en-US" smtClean="0"/>
-              <a:t>10/24/2025</a:t>
+              <a:t>10/27/2025</a:t>
             </a:fld>
             <a:endParaRPr lang="en-US"/>
           </a:p>
@@ -2096,7 +2096,7 @@
           <a:p>
             <a:fld id="{C9D56EB1-F2BE-4898-8B6B-5560BA3C98FF}" type="datetimeFigureOut">
               <a:rPr lang="en-US" smtClean="0"/>
-              <a:t>10/24/2025</a:t>
+              <a:t>10/27/2025</a:t>
             </a:fld>
             <a:endParaRPr lang="en-US"/>
           </a:p>
@@ -2353,7 +2353,7 @@
           <a:p>
             <a:fld id="{C9D56EB1-F2BE-4898-8B6B-5560BA3C98FF}" type="datetimeFigureOut">
               <a:rPr lang="en-US" smtClean="0"/>
-              <a:t>10/24/2025</a:t>
+              <a:t>10/27/2025</a:t>
             </a:fld>
             <a:endParaRPr lang="en-US"/>
           </a:p>
@@ -2566,7 +2566,7 @@
           <a:p>
             <a:fld id="{C9D56EB1-F2BE-4898-8B6B-5560BA3C98FF}" type="datetimeFigureOut">
               <a:rPr lang="en-US" smtClean="0"/>
-              <a:t>10/24/2025</a:t>
+              <a:t>10/27/2025</a:t>
             </a:fld>
             <a:endParaRPr lang="en-US"/>
           </a:p>
@@ -3145,14 +3145,14 @@
           <p:nvPr>
             <p:extLst>
               <p:ext uri="{D42A27DB-BD31-4B8C-83A1-F6EECF244321}">
-                <p14:modId xmlns:p14="http://schemas.microsoft.com/office/powerpoint/2010/main" val="93245397"/>
+                <p14:modId xmlns:p14="http://schemas.microsoft.com/office/powerpoint/2010/main" val="678381363"/>
               </p:ext>
             </p:extLst>
           </p:nvPr>
         </p:nvGraphicFramePr>
         <p:xfrm>
           <a:off x="79939" y="4419130"/>
-          <a:ext cx="10609404" cy="10636800"/>
+          <a:ext cx="10609404" cy="11612160"/>
         </p:xfrm>
         <a:graphic>
           <a:graphicData uri="http://schemas.openxmlformats.org/drawingml/2006/table">
@@ -3406,7 +3406,7 @@
                           <a:latin typeface="TH SarabunPSK" panose="020B0500040200020003" pitchFamily="34" charset="-34"/>
                           <a:cs typeface="TH SarabunPSK" panose="020B0500040200020003" pitchFamily="34" charset="-34"/>
                         </a:rPr>
-                        <a:t>Ischaemic Heart Disease is the leading cause of death world-wide responsible for 13% of all deaths. Ischaemic Heart Disease presents in acute cases as acute coronary syndromes (ACS). In acute coronary syndromes there is  need to reduce the time from the patient getting through the hospital door to the time of definitive treatment with balloon catheterization</a:t>
+                        <a:t>Ischaemic Heart Disease is the leading cause of death world-wide responsible for 13% of all deaths</a:t>
                       </a:r>
                       <a:r>
                         <a:rPr lang="en-GB" sz="3200" i="0" baseline="30000" dirty="0">
@@ -3423,6 +3423,33 @@
                           <a:latin typeface="TH SarabunPSK" panose="020B0500040200020003" pitchFamily="34" charset="-34"/>
                           <a:cs typeface="TH SarabunPSK" panose="020B0500040200020003" pitchFamily="34" charset="-34"/>
                         </a:rPr>
+                        <a:t>. Ischaemic Heart Disease presents in emergency cases as acute coronary syndromes (ACS). In ACS there is  need to reduce the time from the patient getting through the hospital door to the time of definitive treatment with balloon catheterization</a:t>
+                      </a:r>
+                      <a:r>
+                        <a:rPr lang="en-GB" sz="3200" i="0" baseline="30000" dirty="0">
+                          <a:solidFill>
+                            <a:srgbClr val="0070C0"/>
+                          </a:solidFill>
+                          <a:latin typeface="TH SarabunPSK" panose="020B0500040200020003" pitchFamily="34" charset="-34"/>
+                          <a:cs typeface="TH SarabunPSK" panose="020B0500040200020003" pitchFamily="34" charset="-34"/>
+                        </a:rPr>
+                        <a:t>2 </a:t>
+                      </a:r>
+                      <a:r>
+                        <a:rPr lang="en-GB" sz="3200" i="0" baseline="0" dirty="0">
+                          <a:solidFill>
+                            <a:schemeClr val="tx1"/>
+                          </a:solidFill>
+                          <a:latin typeface="TH SarabunPSK" panose="020B0500040200020003" pitchFamily="34" charset="-34"/>
+                          <a:cs typeface="TH SarabunPSK" panose="020B0500040200020003" pitchFamily="34" charset="-34"/>
+                        </a:rPr>
+                        <a:t> (door to balloon time)</a:t>
+                      </a:r>
+                      <a:r>
+                        <a:rPr lang="en-GB" sz="3200" i="0" dirty="0">
+                          <a:latin typeface="TH SarabunPSK" panose="020B0500040200020003" pitchFamily="34" charset="-34"/>
+                          <a:cs typeface="TH SarabunPSK" panose="020B0500040200020003" pitchFamily="34" charset="-34"/>
+                        </a:rPr>
                         <a:t>. Artificial Intelligence systems have been implemented for automatic detection of ST elevated Myocardial Infarction (STEMI) from ECG</a:t>
                       </a:r>
                       <a:r>
@@ -3443,21 +3470,21 @@
                           <a:latin typeface="TH SarabunPSK" panose="020B0500040200020003" pitchFamily="34" charset="-34"/>
                           <a:cs typeface="TH SarabunPSK" panose="020B0500040200020003" pitchFamily="34" charset="-34"/>
                         </a:rPr>
-                        <a:t>2</a:t>
+                        <a:t>3</a:t>
                       </a:r>
                       <a:r>
                         <a:rPr lang="en-GB" sz="3200" i="0" baseline="0" dirty="0">
                           <a:latin typeface="TH SarabunPSK" panose="020B0500040200020003" pitchFamily="34" charset="-34"/>
                           <a:cs typeface="TH SarabunPSK" panose="020B0500040200020003" pitchFamily="34" charset="-34"/>
                         </a:rPr>
-                        <a:t>. </a:t>
+                        <a:t>. Linking these</a:t>
                       </a:r>
                       <a:r>
                         <a:rPr lang="en-GB" sz="3200" i="0" dirty="0">
                           <a:latin typeface="TH SarabunPSK" panose="020B0500040200020003" pitchFamily="34" charset="-34"/>
                           <a:cs typeface="TH SarabunPSK" panose="020B0500040200020003" pitchFamily="34" charset="-34"/>
                         </a:rPr>
-                        <a:t>These platforms have been linked with automatic activation of the Cardiac Catheterization Lab </a:t>
+                        <a:t> platforms to notification systems has been demonstrated to reduce the door to balloon time</a:t>
                       </a:r>
                       <a:r>
                         <a:rPr lang="en-GB" sz="3200" i="0" baseline="30000" dirty="0">
@@ -3467,14 +3494,14 @@
                           <a:latin typeface="TH SarabunPSK" panose="020B0500040200020003" pitchFamily="34" charset="-34"/>
                           <a:cs typeface="TH SarabunPSK" panose="020B0500040200020003" pitchFamily="34" charset="-34"/>
                         </a:rPr>
-                        <a:t>2</a:t>
+                        <a:t>3</a:t>
                       </a:r>
                       <a:r>
                         <a:rPr lang="en-GB" sz="3200" i="0" dirty="0">
                           <a:latin typeface="TH SarabunPSK" panose="020B0500040200020003" pitchFamily="34" charset="-34"/>
                           <a:cs typeface="TH SarabunPSK" panose="020B0500040200020003" pitchFamily="34" charset="-34"/>
                         </a:rPr>
-                        <a:t>. This has been demonstrated to reduce the door to balloon time.  </a:t>
+                        <a:t>. </a:t>
                       </a:r>
                     </a:p>
                     <a:p>
@@ -3499,7 +3526,7 @@
                           <a:latin typeface="TH SarabunPSK" panose="020B0500040200020003" pitchFamily="34" charset="-34"/>
                           <a:cs typeface="TH SarabunPSK" panose="020B0500040200020003" pitchFamily="34" charset="-34"/>
                         </a:rPr>
-                        <a:t>However, to decide to send the patient for emergency cardiac catheterisation it is important to consider the patient’s presenting history, ECG results and the results of lab investigations. As soon as the decision is made the Team that works in the catheterisation lab must be notified to prepare for the patient. Our research looks at using a LLM to use text in the Electronic Health Record (EHR) which includes the History of Presenting illness (HPI), Physical Examination, ECG report and lab results (Troponin results) to automatically make the decision and send a notification to the catheterisation lab. Essentially this is two class medical  classification. </a:t>
+                        <a:t>However, to decide to send the patient for emergency cardiac catheterisation it is important to consider the patient’s presenting history, ECG results and the results of lab investigations. Our research looks at using a LLM to classify text in the Electronic Health Record (EHR) which includes the History of Presenting illness (HPI), Physical Examination, ECG report and lab results (Troponin results) to automatically make the decision and send a notification to the catheterisation lab. Essentially this is a two-class medical  classification. </a:t>
                       </a:r>
                     </a:p>
                     <a:p>
@@ -3521,21 +3548,76 @@
                       </a:pPr>
                       <a:r>
                         <a:rPr lang="en-GB" sz="3200" i="0" dirty="0">
-                          <a:highlight>
-                            <a:srgbClr val="FF0000"/>
-                          </a:highlight>
                           <a:latin typeface="TH SarabunPSK" panose="020B0500040200020003" pitchFamily="34" charset="-34"/>
                           <a:cs typeface="TH SarabunPSK" panose="020B0500040200020003" pitchFamily="34" charset="-34"/>
                         </a:rPr>
-                        <a:t>In previous work …., citations, </a:t>
+                        <a:t>Previous work has been done on classification of medical text using various Machine Learning models including gradient boosting with Text Frequency – Inverse Document Frequency (TF-IDF)</a:t>
                       </a:r>
-                      <a:endParaRPr sz="2800" i="0" dirty="0">
-                        <a:highlight>
-                          <a:srgbClr val="FF0000"/>
-                        </a:highlight>
-                        <a:latin typeface="TH SarabunPSK" panose="020B0500040200020003" pitchFamily="34" charset="-34"/>
-                        <a:cs typeface="TH SarabunPSK" panose="020B0500040200020003" pitchFamily="34" charset="-34"/>
-                      </a:endParaRPr>
+                      <a:r>
+                        <a:rPr lang="en-GB" sz="3200" i="0" baseline="30000" dirty="0">
+                          <a:solidFill>
+                            <a:srgbClr val="0070C0"/>
+                          </a:solidFill>
+                          <a:latin typeface="TH SarabunPSK" panose="020B0500040200020003" pitchFamily="34" charset="-34"/>
+                          <a:cs typeface="TH SarabunPSK" panose="020B0500040200020003" pitchFamily="34" charset="-34"/>
+                        </a:rPr>
+                        <a:t>5</a:t>
+                      </a:r>
+                      <a:r>
+                        <a:rPr lang="en-GB" sz="3200" i="0" dirty="0">
+                          <a:latin typeface="TH SarabunPSK" panose="020B0500040200020003" pitchFamily="34" charset="-34"/>
+                          <a:cs typeface="TH SarabunPSK" panose="020B0500040200020003" pitchFamily="34" charset="-34"/>
+                        </a:rPr>
+                        <a:t> and Transformers. Recently LLMs have been shown to perform well in medical text classification</a:t>
+                      </a:r>
+                      <a:r>
+                        <a:rPr lang="en-GB" sz="3200" i="0" baseline="30000" dirty="0">
+                          <a:solidFill>
+                            <a:srgbClr val="0070C0"/>
+                          </a:solidFill>
+                          <a:latin typeface="TH SarabunPSK" panose="020B0500040200020003" pitchFamily="34" charset="-34"/>
+                          <a:cs typeface="TH SarabunPSK" panose="020B0500040200020003" pitchFamily="34" charset="-34"/>
+                        </a:rPr>
+                        <a:t>6</a:t>
+                      </a:r>
+                      <a:r>
+                        <a:rPr lang="en-GB" sz="3200" i="0" dirty="0">
+                          <a:latin typeface="TH SarabunPSK" panose="020B0500040200020003" pitchFamily="34" charset="-34"/>
+                          <a:cs typeface="TH SarabunPSK" panose="020B0500040200020003" pitchFamily="34" charset="-34"/>
+                        </a:rPr>
+                        <a:t>. We aim to improve the performance of simple transformer model (</a:t>
+                      </a:r>
+                      <a:r>
+                        <a:rPr lang="en-GB" sz="3200" i="0" dirty="0" err="1">
+                          <a:latin typeface="TH SarabunPSK" panose="020B0500040200020003" pitchFamily="34" charset="-34"/>
+                          <a:cs typeface="TH SarabunPSK" panose="020B0500040200020003" pitchFamily="34" charset="-34"/>
+                        </a:rPr>
+                        <a:t>Bio_ClinicalBERT</a:t>
+                      </a:r>
+                      <a:r>
+                        <a:rPr lang="en-GB" sz="3200" i="0" dirty="0">
+                          <a:latin typeface="TH SarabunPSK" panose="020B0500040200020003" pitchFamily="34" charset="-34"/>
+                          <a:cs typeface="TH SarabunPSK" panose="020B0500040200020003" pitchFamily="34" charset="-34"/>
+                        </a:rPr>
+                        <a:t>) with knowledge graph</a:t>
+                      </a:r>
+                      <a:r>
+                        <a:rPr lang="en-GB" sz="3200" i="0" baseline="30000" dirty="0">
+                          <a:solidFill>
+                            <a:srgbClr val="0070C0"/>
+                          </a:solidFill>
+                          <a:latin typeface="TH SarabunPSK" panose="020B0500040200020003" pitchFamily="34" charset="-34"/>
+                          <a:cs typeface="TH SarabunPSK" panose="020B0500040200020003" pitchFamily="34" charset="-34"/>
+                        </a:rPr>
+                        <a:t>7</a:t>
+                      </a:r>
+                      <a:r>
+                        <a:rPr lang="en-GB" sz="3200" i="0" dirty="0">
+                          <a:latin typeface="TH SarabunPSK" panose="020B0500040200020003" pitchFamily="34" charset="-34"/>
+                          <a:cs typeface="TH SarabunPSK" panose="020B0500040200020003" pitchFamily="34" charset="-34"/>
+                        </a:rPr>
+                        <a:t>.</a:t>
+                      </a:r>
                     </a:p>
                   </a:txBody>
                   <a:tcPr marL="0" marR="0" marT="3810" marB="0">
@@ -4251,21 +4333,21 @@
           <p:nvPr>
             <p:extLst>
               <p:ext uri="{D42A27DB-BD31-4B8C-83A1-F6EECF244321}">
-                <p14:modId xmlns:p14="http://schemas.microsoft.com/office/powerpoint/2010/main" val="1571992389"/>
+                <p14:modId xmlns:p14="http://schemas.microsoft.com/office/powerpoint/2010/main" val="4097946602"/>
               </p:ext>
             </p:extLst>
           </p:nvPr>
         </p:nvGraphicFramePr>
         <p:xfrm>
-          <a:off x="10698162" y="20899120"/>
-          <a:ext cx="10534077" cy="8108644"/>
+          <a:off x="10689344" y="20899120"/>
+          <a:ext cx="10542896" cy="9256290"/>
         </p:xfrm>
         <a:graphic>
           <a:graphicData uri="http://schemas.openxmlformats.org/drawingml/2006/table">
             <a:tbl>
               <a:tblPr firstRow="1" bandRow="1"/>
               <a:tblGrid>
-                <a:gridCol w="10534077">
+                <a:gridCol w="10542896">
                   <a:extLst>
                     <a:ext uri="{9D8B030D-6E8A-4147-A177-3AD203B41FA5}">
                       <a16:colId xmlns:a16="http://schemas.microsoft.com/office/drawing/2014/main" val="20000"/>
@@ -4498,7 +4580,7 @@
                           <a:latin typeface="TH SarabunPSK" panose="020B0500040200020003" pitchFamily="34" charset="-34"/>
                           <a:cs typeface="TH SarabunPSK" panose="020B0500040200020003" pitchFamily="34" charset="-34"/>
                         </a:rPr>
-                        <a:t>1. Cannon CP, G. C. (2000). Relationship of Symptom-Onset-to-Balloon Time and Door-to-Balloon Time With Mortality in Patients Undergoing Angioplasty for Acute Myocardial Infarction. JAMA, 22(283), 2941–2947. Retrieved from doi:10.1001/jama.283.22.2941</a:t>
+                        <a:t>1. Lindstrom, M., DeCleene, N., Dorsey, et al (2022). Global Burden of Cardiovascular Diseases and Risks Collaboration, 1990-2021. Journal of the American College of Cardiology, 80(25), 2372–2425. https://doi.org/10.1016/j.jacc.2022.11.001</a:t>
                       </a:r>
                     </a:p>
                     <a:p>
@@ -4512,7 +4594,7 @@
                           <a:latin typeface="TH SarabunPSK" panose="020B0500040200020003" pitchFamily="34" charset="-34"/>
                           <a:cs typeface="TH SarabunPSK" panose="020B0500040200020003" pitchFamily="34" charset="-34"/>
                         </a:rPr>
-                        <a:t>2. Robert Avram, William F. Fearon. (2024, 7 1). NEJM AI, 1(7). doi:10.1056/AIe2400472</a:t>
+                        <a:t>2. Cannon CP, G. C. (2000). Relationship of Symptom-Onset-to-Balloon Time and Door-to-Balloon Time With Mortality in Patients Undergoing Angioplasty for Acute Myocardial Infarction. JAMA, 22(283), 2941–2947. Retrieved from doi:10.1001/jama.283.22.2941</a:t>
                       </a:r>
                     </a:p>
                     <a:p>
@@ -4526,7 +4608,7 @@
                           <a:latin typeface="TH SarabunPSK" panose="020B0500040200020003" pitchFamily="34" charset="-34"/>
                           <a:cs typeface="TH SarabunPSK" panose="020B0500040200020003" pitchFamily="34" charset="-34"/>
                         </a:rPr>
-                        <a:t>3. Sunil V. Rao, M. L. (2025). 2025 ACC/AHA/ACEP/NAEMSP/SCAI Guideline for the Management of Patients With Acute Coronary Syndromes: A Report of the American College of Cardiology/American Heart Association Joint Committee on Clinical Practice Guidelines. Circulation, 151(13).</a:t>
+                        <a:t>3. Robert Avram, William F. Fearon. (2024, 7 1). NEJM AI, 1(7). doi:10.1056/AIe2400472</a:t>
                       </a:r>
                     </a:p>
                     <a:p>
@@ -4540,7 +4622,21 @@
                           <a:latin typeface="TH SarabunPSK" panose="020B0500040200020003" pitchFamily="34" charset="-34"/>
                           <a:cs typeface="TH SarabunPSK" panose="020B0500040200020003" pitchFamily="34" charset="-34"/>
                         </a:rPr>
-                        <a:t>4. Maarten Falter, Dries </a:t>
+                        <a:t>4. Sunil V. Rao, M. L. (2025). 2025 ACC/AHA/ACEP/NAEMSP/SCAI Guideline for the Management of Patients With Acute Coronary Syndromes: A Report of the American College of Cardiology/American Heart Association Joint Committee on Clinical Practice Guidelines. Circulation, 151(13).</a:t>
+                      </a:r>
+                    </a:p>
+                    <a:p>
+                      <a:pPr marL="182880">
+                        <a:lnSpc>
+                          <a:spcPct val="100000"/>
+                        </a:lnSpc>
+                      </a:pPr>
+                      <a:r>
+                        <a:rPr lang="en-GB" sz="2400" dirty="0">
+                          <a:latin typeface="TH SarabunPSK" panose="020B0500040200020003" pitchFamily="34" charset="-34"/>
+                          <a:cs typeface="TH SarabunPSK" panose="020B0500040200020003" pitchFamily="34" charset="-34"/>
+                        </a:rPr>
+                        <a:t>5. Maarten Falter, Dries </a:t>
                       </a:r>
                       <a:r>
                         <a:rPr lang="en-GB" sz="2400" dirty="0" err="1">
@@ -4570,7 +4666,130 @@
                         </a:rPr>
                         <a:t>, et al, Using natural language processing for automated classification of disease and to identify misclassified ICD codes in cardiac disease, European Heart Journal - Digital Health, Volume 5, Issue 3, May 2024, Pages 229–234, https://doi.org/10.1093/ehjdh/ztae008</a:t>
                       </a:r>
-                      <a:endParaRPr lang="en-ZA" sz="2400" dirty="0">
+                    </a:p>
+                    <a:p>
+                      <a:pPr marL="182880">
+                        <a:lnSpc>
+                          <a:spcPct val="100000"/>
+                        </a:lnSpc>
+                      </a:pPr>
+                      <a:r>
+                        <a:rPr lang="en-GB" sz="2400" dirty="0">
+                          <a:latin typeface="TH SarabunPSK" panose="020B0500040200020003" pitchFamily="34" charset="-34"/>
+                          <a:cs typeface="TH SarabunPSK" panose="020B0500040200020003" pitchFamily="34" charset="-34"/>
+                        </a:rPr>
+                        <a:t>6. Matos, J., </a:t>
+                      </a:r>
+                      <a:r>
+                        <a:rPr lang="en-GB" sz="2400" dirty="0" err="1">
+                          <a:latin typeface="TH SarabunPSK" panose="020B0500040200020003" pitchFamily="34" charset="-34"/>
+                          <a:cs typeface="TH SarabunPSK" panose="020B0500040200020003" pitchFamily="34" charset="-34"/>
+                        </a:rPr>
+                        <a:t>Gallifant</a:t>
+                      </a:r>
+                      <a:r>
+                        <a:rPr lang="en-GB" sz="2400" dirty="0">
+                          <a:latin typeface="TH SarabunPSK" panose="020B0500040200020003" pitchFamily="34" charset="-34"/>
+                          <a:cs typeface="TH SarabunPSK" panose="020B0500040200020003" pitchFamily="34" charset="-34"/>
+                        </a:rPr>
+                        <a:t>, J., Pei, J., Wong, A.I. (2025). </a:t>
+                      </a:r>
+                      <a:r>
+                        <a:rPr lang="en-GB" sz="2400" dirty="0" err="1">
+                          <a:latin typeface="TH SarabunPSK" panose="020B0500040200020003" pitchFamily="34" charset="-34"/>
+                          <a:cs typeface="TH SarabunPSK" panose="020B0500040200020003" pitchFamily="34" charset="-34"/>
+                        </a:rPr>
+                        <a:t>EHRmonize</a:t>
+                      </a:r>
+                      <a:r>
+                        <a:rPr lang="en-GB" sz="2400" dirty="0">
+                          <a:latin typeface="TH SarabunPSK" panose="020B0500040200020003" pitchFamily="34" charset="-34"/>
+                          <a:cs typeface="TH SarabunPSK" panose="020B0500040200020003" pitchFamily="34" charset="-34"/>
+                        </a:rPr>
+                        <a:t>: A Framework for Medical Concept Abstraction from Electronic Health Records using Large Language Models. In: Wu, S., </a:t>
+                      </a:r>
+                      <a:r>
+                        <a:rPr lang="en-GB" sz="2400" dirty="0" err="1">
+                          <a:latin typeface="TH SarabunPSK" panose="020B0500040200020003" pitchFamily="34" charset="-34"/>
+                          <a:cs typeface="TH SarabunPSK" panose="020B0500040200020003" pitchFamily="34" charset="-34"/>
+                        </a:rPr>
+                        <a:t>Shabestari</a:t>
+                      </a:r>
+                      <a:r>
+                        <a:rPr lang="en-GB" sz="2400" dirty="0">
+                          <a:latin typeface="TH SarabunPSK" panose="020B0500040200020003" pitchFamily="34" charset="-34"/>
+                          <a:cs typeface="TH SarabunPSK" panose="020B0500040200020003" pitchFamily="34" charset="-34"/>
+                        </a:rPr>
+                        <a:t>, B., Xing, L. (eds) Applications of Medical Artificial Intelligence. AMAI 2024. Lecture Notes in Computer Science, vol 15384. Springer, Cham. </a:t>
+                      </a:r>
+                      <a:r>
+                        <a:rPr lang="en-GB" sz="2400" dirty="0">
+                          <a:latin typeface="TH SarabunPSK" panose="020B0500040200020003" pitchFamily="34" charset="-34"/>
+                          <a:cs typeface="TH SarabunPSK" panose="020B0500040200020003" pitchFamily="34" charset="-34"/>
+                          <a:hlinkClick r:id="rId2"/>
+                        </a:rPr>
+                        <a:t>https://doi.org/10.1007/978-3-031-82007-6_20</a:t>
+                      </a:r>
+                      <a:endParaRPr lang="en-GB" sz="2400" dirty="0">
+                        <a:latin typeface="TH SarabunPSK" panose="020B0500040200020003" pitchFamily="34" charset="-34"/>
+                        <a:cs typeface="TH SarabunPSK" panose="020B0500040200020003" pitchFamily="34" charset="-34"/>
+                      </a:endParaRPr>
+                    </a:p>
+                    <a:p>
+                      <a:pPr marL="182880">
+                        <a:lnSpc>
+                          <a:spcPct val="100000"/>
+                        </a:lnSpc>
+                      </a:pPr>
+                      <a:r>
+                        <a:rPr lang="en-GB" sz="2400" dirty="0">
+                          <a:latin typeface="TH SarabunPSK" panose="020B0500040200020003" pitchFamily="34" charset="-34"/>
+                          <a:cs typeface="TH SarabunPSK" panose="020B0500040200020003" pitchFamily="34" charset="-34"/>
+                        </a:rPr>
+                        <a:t>7. Wang, H., Zu, Q., Lu, M., Chen, R., Yang, Z., Gao, Y., &amp; Ding, J. (2022). Application of Medical Knowledge Graphs in Cardiology and Cardiovascular Medicine: A Brief Literature Review. Advances in therapy, 39(9), 4052–4060. </a:t>
+                      </a:r>
+                      <a:r>
+                        <a:rPr lang="en-GB" sz="2400" dirty="0">
+                          <a:latin typeface="TH SarabunPSK" panose="020B0500040200020003" pitchFamily="34" charset="-34"/>
+                          <a:cs typeface="TH SarabunPSK" panose="020B0500040200020003" pitchFamily="34" charset="-34"/>
+                          <a:hlinkClick r:id="rId3"/>
+                        </a:rPr>
+                        <a:t>https://doi.org/10.1007/s12325-022-02254-7</a:t>
+                      </a:r>
+                      <a:endParaRPr lang="en-GB" sz="2400" dirty="0">
+                        <a:latin typeface="TH SarabunPSK" panose="020B0500040200020003" pitchFamily="34" charset="-34"/>
+                        <a:cs typeface="TH SarabunPSK" panose="020B0500040200020003" pitchFamily="34" charset="-34"/>
+                      </a:endParaRPr>
+                    </a:p>
+                    <a:p>
+                      <a:pPr marL="182880">
+                        <a:lnSpc>
+                          <a:spcPct val="100000"/>
+                        </a:lnSpc>
+                      </a:pPr>
+                      <a:endParaRPr lang="en-GB" sz="2400" dirty="0">
+                        <a:latin typeface="TH SarabunPSK" panose="020B0500040200020003" pitchFamily="34" charset="-34"/>
+                        <a:cs typeface="TH SarabunPSK" panose="020B0500040200020003" pitchFamily="34" charset="-34"/>
+                      </a:endParaRPr>
+                    </a:p>
+                    <a:p>
+                      <a:pPr marL="182880">
+                        <a:lnSpc>
+                          <a:spcPct val="100000"/>
+                        </a:lnSpc>
+                      </a:pPr>
+                      <a:endParaRPr lang="en-GB" sz="2400" dirty="0">
+                        <a:latin typeface="TH SarabunPSK" panose="020B0500040200020003" pitchFamily="34" charset="-34"/>
+                        <a:cs typeface="TH SarabunPSK" panose="020B0500040200020003" pitchFamily="34" charset="-34"/>
+                      </a:endParaRPr>
+                    </a:p>
+                    <a:p>
+                      <a:pPr marL="182880">
+                        <a:lnSpc>
+                          <a:spcPct val="100000"/>
+                        </a:lnSpc>
+                      </a:pPr>
+                      <a:endParaRPr lang="en-GB" sz="2400" dirty="0">
                         <a:latin typeface="TH SarabunPSK" panose="020B0500040200020003" pitchFamily="34" charset="-34"/>
                         <a:cs typeface="TH SarabunPSK" panose="020B0500040200020003" pitchFamily="34" charset="-34"/>
                       </a:endParaRPr>
@@ -5758,7 +5977,7 @@
           <p:nvPr/>
         </p:nvPicPr>
         <p:blipFill>
-          <a:blip r:embed="rId2">
+          <a:blip r:embed="rId4">
             <a:extLst>
               <a:ext uri="{28A0092B-C50C-407E-A947-70E740481C1C}">
                 <a14:useLocalDpi xmlns:a14="http://schemas.microsoft.com/office/drawing/2010/main" val="0"/>
@@ -5805,7 +6024,7 @@
           <p:nvPr/>
         </p:nvPicPr>
         <p:blipFill>
-          <a:blip r:embed="rId2">
+          <a:blip r:embed="rId4">
             <a:extLst>
               <a:ext uri="{28A0092B-C50C-407E-A947-70E740481C1C}">
                 <a14:useLocalDpi xmlns:a14="http://schemas.microsoft.com/office/drawing/2010/main" val="0"/>
@@ -8716,7 +8935,7 @@
           <p:nvPr/>
         </p:nvPicPr>
         <p:blipFill>
-          <a:blip r:embed="rId3">
+          <a:blip r:embed="rId5">
             <a:extLst>
               <a:ext uri="{28A0092B-C50C-407E-A947-70E740481C1C}">
                 <a14:useLocalDpi xmlns:a14="http://schemas.microsoft.com/office/drawing/2010/main" val="0"/>

</xml_diff>